<commit_message>
docs(presentation): clarify report grouping
</commit_message>
<xml_diff>
--- a/EOL_Tracker_Project_Overview.pptx
+++ b/EOL_Tracker_Project_Overview.pptx
@@ -2,22 +2,22 @@
 <file path=ppt/presentation.xml><?xml version="1.0" encoding="utf-8"?>
 <p:presentation xmlns:p="http://schemas.openxmlformats.org/presentationml/2006/main">
   <p:sldMasterIdLst>
-    <p:sldMasterId xmlns:r="http://schemas.openxmlformats.org/officeDocument/2006/relationships" id="2147483648" r:id="R45905be5d2e94f42"/>
+    <p:sldMasterId xmlns:r="http://schemas.openxmlformats.org/officeDocument/2006/relationships" id="2147483648" r:id="R2d706d72695b4dc8"/>
   </p:sldMasterIdLst>
   <p:notesMasterIdLst>
-    <p:notesMasterId xmlns:r="http://schemas.openxmlformats.org/officeDocument/2006/relationships" r:id="R9053c6a8026d4fed"/>
+    <p:notesMasterId xmlns:r="http://schemas.openxmlformats.org/officeDocument/2006/relationships" r:id="R0ce087977a4e472d"/>
   </p:notesMasterIdLst>
   <p:sldIdLst>
-    <p:sldId xmlns:r="http://schemas.openxmlformats.org/officeDocument/2006/relationships" id="256" r:id="Rfe952431408e4965"/>
-    <p:sldId xmlns:r="http://schemas.openxmlformats.org/officeDocument/2006/relationships" id="257" r:id="R701d76cdab3849c5"/>
-    <p:sldId xmlns:r="http://schemas.openxmlformats.org/officeDocument/2006/relationships" id="258" r:id="R2b2ef97cde724ca4"/>
-    <p:sldId xmlns:r="http://schemas.openxmlformats.org/officeDocument/2006/relationships" id="259" r:id="Rd20607978db54359"/>
-    <p:sldId xmlns:r="http://schemas.openxmlformats.org/officeDocument/2006/relationships" id="260" r:id="Rd664cad41599417f"/>
-    <p:sldId xmlns:r="http://schemas.openxmlformats.org/officeDocument/2006/relationships" id="261" r:id="Ra49c03c05364496a"/>
-    <p:sldId xmlns:r="http://schemas.openxmlformats.org/officeDocument/2006/relationships" id="262" r:id="R7ed71d82e0994f70"/>
-    <p:sldId xmlns:r="http://schemas.openxmlformats.org/officeDocument/2006/relationships" id="263" r:id="R5beb8192039c4bf1"/>
-    <p:sldId xmlns:r="http://schemas.openxmlformats.org/officeDocument/2006/relationships" id="264" r:id="R10f620428f634860"/>
-    <p:sldId xmlns:r="http://schemas.openxmlformats.org/officeDocument/2006/relationships" id="265" r:id="R29187243bf134288"/>
+    <p:sldId xmlns:r="http://schemas.openxmlformats.org/officeDocument/2006/relationships" id="256" r:id="R2dc8149004564712"/>
+    <p:sldId xmlns:r="http://schemas.openxmlformats.org/officeDocument/2006/relationships" id="257" r:id="R04ecc9565474465f"/>
+    <p:sldId xmlns:r="http://schemas.openxmlformats.org/officeDocument/2006/relationships" id="258" r:id="R42c9b08f69494f0c"/>
+    <p:sldId xmlns:r="http://schemas.openxmlformats.org/officeDocument/2006/relationships" id="259" r:id="R83ea67ea9c6d4617"/>
+    <p:sldId xmlns:r="http://schemas.openxmlformats.org/officeDocument/2006/relationships" id="260" r:id="R4fcbc2eb5a2741f1"/>
+    <p:sldId xmlns:r="http://schemas.openxmlformats.org/officeDocument/2006/relationships" id="261" r:id="Rff5e3c602f1e4893"/>
+    <p:sldId xmlns:r="http://schemas.openxmlformats.org/officeDocument/2006/relationships" id="262" r:id="Rbc26cf9384f74097"/>
+    <p:sldId xmlns:r="http://schemas.openxmlformats.org/officeDocument/2006/relationships" id="263" r:id="R6820e37b1c3b422f"/>
+    <p:sldId xmlns:r="http://schemas.openxmlformats.org/officeDocument/2006/relationships" id="264" r:id="R99988d1dbcd749b5"/>
+    <p:sldId xmlns:r="http://schemas.openxmlformats.org/officeDocument/2006/relationships" id="265" r:id="Rbffcaf8b477b4b3c"/>
   </p:sldIdLst>
   <p:sldSz cx="12192000" cy="6858000"/>
   <p:notesSz cx="6858000" cy="9144000"/>
@@ -1424,7 +1424,7 @@
   </p:cSld>
   <p:clrMap bg1="lt1" tx1="dk1" bg2="lt2" tx2="dk2" accent1="accent1" accent2="accent2" accent3="accent3" accent4="accent4" accent5="accent5" accent6="accent6" hlink="hlink" folHlink="folHlink"/>
   <p:sldLayoutIdLst>
-    <p:sldLayoutId xmlns:r="http://schemas.openxmlformats.org/officeDocument/2006/relationships" id="2147483649" r:id="Rfa8d79b2b8874c77"/>
+    <p:sldLayoutId xmlns:r="http://schemas.openxmlformats.org/officeDocument/2006/relationships" id="2147483649" r:id="Rcb9e301f55be436d"/>
   </p:sldLayoutIdLst>
   <p:txStyles>
     <p:titleStyle>
@@ -5316,7 +5316,7 @@
                 <a:ea typeface="Arial"/>
                 <a:cs typeface="Arial"/>
               </a:rPr>
-              <a:t>Apply thresholds, group risk, and publish a consistent management view.</a:t>
+              <a:t>Use the 90-day sample alert window, group results by lifecycle status, and publish one report.</a:t>
             </a:r>
           </a:p>
         </p:txBody>

</xml_diff>

<commit_message>
docs(presentation): explain config verification
</commit_message>
<xml_diff>
--- a/EOL_Tracker_Project_Overview.pptx
+++ b/EOL_Tracker_Project_Overview.pptx
@@ -2,22 +2,22 @@
 <file path=ppt/presentation.xml><?xml version="1.0" encoding="utf-8"?>
 <p:presentation xmlns:p="http://schemas.openxmlformats.org/presentationml/2006/main">
   <p:sldMasterIdLst>
-    <p:sldMasterId xmlns:r="http://schemas.openxmlformats.org/officeDocument/2006/relationships" id="2147483648" r:id="R2d706d72695b4dc8"/>
+    <p:sldMasterId xmlns:r="http://schemas.openxmlformats.org/officeDocument/2006/relationships" id="2147483648" r:id="Rf8d188d2a2334f3f"/>
   </p:sldMasterIdLst>
   <p:notesMasterIdLst>
-    <p:notesMasterId xmlns:r="http://schemas.openxmlformats.org/officeDocument/2006/relationships" r:id="R0ce087977a4e472d"/>
+    <p:notesMasterId xmlns:r="http://schemas.openxmlformats.org/officeDocument/2006/relationships" r:id="R293365fe9336484e"/>
   </p:notesMasterIdLst>
   <p:sldIdLst>
-    <p:sldId xmlns:r="http://schemas.openxmlformats.org/officeDocument/2006/relationships" id="256" r:id="R2dc8149004564712"/>
-    <p:sldId xmlns:r="http://schemas.openxmlformats.org/officeDocument/2006/relationships" id="257" r:id="R04ecc9565474465f"/>
-    <p:sldId xmlns:r="http://schemas.openxmlformats.org/officeDocument/2006/relationships" id="258" r:id="R42c9b08f69494f0c"/>
-    <p:sldId xmlns:r="http://schemas.openxmlformats.org/officeDocument/2006/relationships" id="259" r:id="R83ea67ea9c6d4617"/>
-    <p:sldId xmlns:r="http://schemas.openxmlformats.org/officeDocument/2006/relationships" id="260" r:id="R4fcbc2eb5a2741f1"/>
-    <p:sldId xmlns:r="http://schemas.openxmlformats.org/officeDocument/2006/relationships" id="261" r:id="Rff5e3c602f1e4893"/>
-    <p:sldId xmlns:r="http://schemas.openxmlformats.org/officeDocument/2006/relationships" id="262" r:id="Rbc26cf9384f74097"/>
-    <p:sldId xmlns:r="http://schemas.openxmlformats.org/officeDocument/2006/relationships" id="263" r:id="R6820e37b1c3b422f"/>
-    <p:sldId xmlns:r="http://schemas.openxmlformats.org/officeDocument/2006/relationships" id="264" r:id="R99988d1dbcd749b5"/>
-    <p:sldId xmlns:r="http://schemas.openxmlformats.org/officeDocument/2006/relationships" id="265" r:id="Rbffcaf8b477b4b3c"/>
+    <p:sldId xmlns:r="http://schemas.openxmlformats.org/officeDocument/2006/relationships" id="256" r:id="Re7eabeb106884f15"/>
+    <p:sldId xmlns:r="http://schemas.openxmlformats.org/officeDocument/2006/relationships" id="257" r:id="R437986ce4d4b4c9a"/>
+    <p:sldId xmlns:r="http://schemas.openxmlformats.org/officeDocument/2006/relationships" id="258" r:id="Ra0396d64ce3a436a"/>
+    <p:sldId xmlns:r="http://schemas.openxmlformats.org/officeDocument/2006/relationships" id="259" r:id="R8a5ed3e955c24370"/>
+    <p:sldId xmlns:r="http://schemas.openxmlformats.org/officeDocument/2006/relationships" id="260" r:id="R4212d46e06864c2f"/>
+    <p:sldId xmlns:r="http://schemas.openxmlformats.org/officeDocument/2006/relationships" id="261" r:id="Rf34b3ddc2817438c"/>
+    <p:sldId xmlns:r="http://schemas.openxmlformats.org/officeDocument/2006/relationships" id="262" r:id="R3cb4df449c0b4751"/>
+    <p:sldId xmlns:r="http://schemas.openxmlformats.org/officeDocument/2006/relationships" id="263" r:id="R8c663696256c481c"/>
+    <p:sldId xmlns:r="http://schemas.openxmlformats.org/officeDocument/2006/relationships" id="264" r:id="Ra79aaa4fa7894243"/>
+    <p:sldId xmlns:r="http://schemas.openxmlformats.org/officeDocument/2006/relationships" id="265" r:id="R7dc171a5b0de4f5d"/>
   </p:sldIdLst>
   <p:sldSz cx="12192000" cy="6858000"/>
   <p:notesSz cx="6858000" cy="9144000"/>
@@ -1424,7 +1424,7 @@
   </p:cSld>
   <p:clrMap bg1="lt1" tx1="dk1" bg2="lt2" tx2="dk2" accent1="accent1" accent2="accent2" accent3="accent3" accent4="accent4" accent5="accent5" accent6="accent6" hlink="hlink" folHlink="folHlink"/>
   <p:sldLayoutIdLst>
-    <p:sldLayoutId xmlns:r="http://schemas.openxmlformats.org/officeDocument/2006/relationships" id="2147483649" r:id="Rcb9e301f55be436d"/>
+    <p:sldLayoutId xmlns:r="http://schemas.openxmlformats.org/officeDocument/2006/relationships" id="2147483649" r:id="R7a2997545e6e4412"/>
   </p:sldLayoutIdLst>
   <p:txStyles>
     <p:titleStyle>
@@ -6323,7 +6323,7 @@
                 <a:ea typeface="Arial"/>
                 <a:cs typeface="Arial"/>
               </a:rPr>
-              <a:t>Every proposed slug, cycle or package is verified; JSON is validated and the finished configuration is smoke-run.</a:t>
+              <a:t>Slugs, cycles and packages are checked against live lifecycle and registry APIs; JSON is validated and the configuration is smoke-run.</a:t>
             </a:r>
           </a:p>
         </p:txBody>

</xml_diff>